<commit_message>
chore: update output-pptx [main]
</commit_message>
<xml_diff>
--- a/output-pptx/test-output.pptx
+++ b/output-pptx/test-output.pptx
@@ -8467,7 +8467,7 @@
         <p:spPr>
           <a:xfrm>
             <a:off x="909638" y="3702993"/>
-            <a:ext cx="4948238" cy="833289"/>
+            <a:ext cx="4948238" cy="842814"/>
           </a:xfrm>
           <a:prstGeom prst="rect">
             <a:avLst/>
@@ -9583,7 +9583,7 @@
         </p:nvSpPr>
         <p:spPr>
           <a:xfrm>
-            <a:off x="747713" y="2272159"/>
+            <a:off x="747713" y="2267396"/>
             <a:ext cx="11291888" cy="684907"/>
           </a:xfrm>
           <a:prstGeom prst="rect">
@@ -9625,7 +9625,7 @@
         </p:nvSpPr>
         <p:spPr>
           <a:xfrm>
-            <a:off x="747713" y="3164235"/>
+            <a:off x="747713" y="3159472"/>
             <a:ext cx="304800" cy="304800"/>
           </a:xfrm>
           <a:prstGeom prst="roundRect">
@@ -9647,7 +9647,7 @@
         </p:nvSpPr>
         <p:spPr>
           <a:xfrm>
-            <a:off x="747713" y="3164235"/>
+            <a:off x="747713" y="3159472"/>
             <a:ext cx="381000" cy="304800"/>
           </a:xfrm>
           <a:prstGeom prst="rect">
@@ -9689,8 +9689,8 @@
         </p:nvSpPr>
         <p:spPr>
           <a:xfrm>
-            <a:off x="1147763" y="3109466"/>
-            <a:ext cx="3507879" cy="414338"/>
+            <a:off x="1147763" y="3104704"/>
+            <a:ext cx="3705523" cy="414338"/>
           </a:xfrm>
           <a:prstGeom prst="rect">
             <a:avLst/>
@@ -9795,8 +9795,8 @@
         </p:nvSpPr>
         <p:spPr>
           <a:xfrm>
-            <a:off x="1147763" y="3638104"/>
-            <a:ext cx="5512743" cy="418951"/>
+            <a:off x="1147763" y="3633341"/>
+            <a:ext cx="5888831" cy="428476"/>
           </a:xfrm>
           <a:prstGeom prst="rect">
             <a:avLst/>
@@ -9891,7 +9891,7 @@
         </p:nvSpPr>
         <p:spPr>
           <a:xfrm>
-            <a:off x="747713" y="4226123"/>
+            <a:off x="747713" y="4230886"/>
             <a:ext cx="304800" cy="304800"/>
           </a:xfrm>
           <a:prstGeom prst="roundRect">
@@ -9913,7 +9913,7 @@
         </p:nvSpPr>
         <p:spPr>
           <a:xfrm>
-            <a:off x="747713" y="4226123"/>
+            <a:off x="747713" y="4230886"/>
             <a:ext cx="381000" cy="304800"/>
           </a:xfrm>
           <a:prstGeom prst="rect">
@@ -9955,7 +9955,7 @@
         </p:nvSpPr>
         <p:spPr>
           <a:xfrm>
-            <a:off x="1147763" y="4171355"/>
+            <a:off x="1147763" y="4176117"/>
             <a:ext cx="10601325" cy="414338"/>
           </a:xfrm>
           <a:prstGeom prst="rect">
@@ -11079,7 +11079,7 @@
         </p:nvSpPr>
         <p:spPr>
           <a:xfrm>
-            <a:off x="747713" y="1101775"/>
+            <a:off x="747713" y="1097012"/>
             <a:ext cx="11291888" cy="684907"/>
           </a:xfrm>
           <a:prstGeom prst="rect">
@@ -11121,7 +11121,7 @@
         </p:nvSpPr>
         <p:spPr>
           <a:xfrm>
-            <a:off x="747713" y="1939082"/>
+            <a:off x="747713" y="1934319"/>
             <a:ext cx="11001375" cy="414338"/>
           </a:xfrm>
           <a:prstGeom prst="rect">
@@ -11163,8 +11163,8 @@
         </p:nvSpPr>
         <p:spPr>
           <a:xfrm>
-            <a:off x="747713" y="2505819"/>
-            <a:ext cx="10696575" cy="3250257"/>
+            <a:off x="747713" y="2501057"/>
+            <a:ext cx="10696575" cy="3259782"/>
           </a:xfrm>
           <a:prstGeom prst="rect">
             <a:avLst/>
@@ -11810,7 +11810,7 @@
         </p:nvSpPr>
         <p:spPr>
           <a:xfrm>
-            <a:off x="747713" y="1638746"/>
+            <a:off x="747713" y="1632198"/>
             <a:ext cx="11291888" cy="472380"/>
           </a:xfrm>
           <a:prstGeom prst="rect">
@@ -11852,7 +11852,7 @@
         </p:nvSpPr>
         <p:spPr>
           <a:xfrm>
-            <a:off x="747713" y="2339727"/>
+            <a:off x="747713" y="2333179"/>
             <a:ext cx="11291888" cy="383828"/>
           </a:xfrm>
           <a:prstGeom prst="rect">
@@ -11894,7 +11894,7 @@
         </p:nvSpPr>
         <p:spPr>
           <a:xfrm>
-            <a:off x="747713" y="2875955"/>
+            <a:off x="747713" y="2869406"/>
             <a:ext cx="11001375" cy="285750"/>
           </a:xfrm>
           <a:prstGeom prst="rect">
@@ -11936,7 +11936,7 @@
         </p:nvSpPr>
         <p:spPr>
           <a:xfrm>
-            <a:off x="747713" y="3314105"/>
+            <a:off x="747713" y="3307556"/>
             <a:ext cx="5291138" cy="1390650"/>
           </a:xfrm>
           <a:prstGeom prst="roundRect">
@@ -11963,7 +11963,7 @@
         </p:nvSpPr>
         <p:spPr>
           <a:xfrm>
-            <a:off x="747713" y="3314105"/>
+            <a:off x="747713" y="3307556"/>
             <a:ext cx="5367338" cy="1390650"/>
           </a:xfrm>
           <a:prstGeom prst="rect">
@@ -12083,7 +12083,7 @@
         </p:nvSpPr>
         <p:spPr>
           <a:xfrm>
-            <a:off x="6153150" y="3314105"/>
+            <a:off x="6153150" y="3307556"/>
             <a:ext cx="5291138" cy="1390650"/>
           </a:xfrm>
           <a:prstGeom prst="roundRect">
@@ -12110,7 +12110,7 @@
         </p:nvSpPr>
         <p:spPr>
           <a:xfrm>
-            <a:off x="6153150" y="3314105"/>
+            <a:off x="6153150" y="3307556"/>
             <a:ext cx="5672138" cy="1390650"/>
           </a:xfrm>
           <a:prstGeom prst="rect">
@@ -12230,12 +12230,12 @@
         </p:nvSpPr>
         <p:spPr>
           <a:xfrm>
-            <a:off x="747713" y="4780955"/>
-            <a:ext cx="10696575" cy="438150"/>
+            <a:off x="747713" y="4774406"/>
+            <a:ext cx="10696575" cy="451396"/>
           </a:xfrm>
           <a:prstGeom prst="roundRect">
             <a:avLst>
-              <a:gd name="adj" fmla="val 54442"/>
+              <a:gd name="adj" fmla="val 51294"/>
             </a:avLst>
           </a:prstGeom>
           <a:solidFill>
@@ -12257,8 +12257,8 @@
         </p:nvSpPr>
         <p:spPr>
           <a:xfrm>
-            <a:off x="747713" y="4780955"/>
-            <a:ext cx="11077575" cy="438150"/>
+            <a:off x="747713" y="4774406"/>
+            <a:ext cx="11077575" cy="451396"/>
           </a:xfrm>
           <a:prstGeom prst="rect">
             <a:avLst/>
@@ -12413,7 +12413,7 @@
         </p:nvSpPr>
         <p:spPr>
           <a:xfrm>
-            <a:off x="747713" y="1819721"/>
+            <a:off x="747713" y="1814959"/>
             <a:ext cx="11291888" cy="684907"/>
           </a:xfrm>
           <a:prstGeom prst="rect">
@@ -12455,7 +12455,7 @@
         </p:nvSpPr>
         <p:spPr>
           <a:xfrm>
-            <a:off x="747713" y="2657029"/>
+            <a:off x="747713" y="2652266"/>
             <a:ext cx="66675" cy="414338"/>
           </a:xfrm>
           <a:prstGeom prst="rect">
@@ -12475,7 +12475,7 @@
         </p:nvSpPr>
         <p:spPr>
           <a:xfrm>
-            <a:off x="814388" y="2657029"/>
+            <a:off x="814388" y="2652266"/>
             <a:ext cx="10629900" cy="414338"/>
           </a:xfrm>
           <a:prstGeom prst="rect">
@@ -12517,7 +12517,7 @@
         </p:nvSpPr>
         <p:spPr>
           <a:xfrm>
-            <a:off x="747713" y="3223766"/>
+            <a:off x="747713" y="3219004"/>
             <a:ext cx="66675" cy="1243013"/>
           </a:xfrm>
           <a:prstGeom prst="rect">
@@ -12537,7 +12537,7 @@
         </p:nvSpPr>
         <p:spPr>
           <a:xfrm>
-            <a:off x="814388" y="3223766"/>
+            <a:off x="814388" y="3219004"/>
             <a:ext cx="10629900" cy="1243013"/>
           </a:xfrm>
           <a:prstGeom prst="rect">
@@ -12631,8 +12631,8 @@
         </p:nvSpPr>
         <p:spPr>
           <a:xfrm>
-            <a:off x="747713" y="4619179"/>
-            <a:ext cx="66675" cy="418951"/>
+            <a:off x="747713" y="4614416"/>
+            <a:ext cx="66675" cy="428476"/>
           </a:xfrm>
           <a:prstGeom prst="rect">
             <a:avLst/>
@@ -12651,8 +12651,8 @@
         </p:nvSpPr>
         <p:spPr>
           <a:xfrm>
-            <a:off x="814388" y="4619179"/>
-            <a:ext cx="10629900" cy="418951"/>
+            <a:off x="814388" y="4614416"/>
+            <a:ext cx="10629900" cy="428476"/>
           </a:xfrm>
           <a:prstGeom prst="rect">
             <a:avLst/>
@@ -12858,7 +12858,7 @@
         </p:nvSpPr>
         <p:spPr>
           <a:xfrm>
-            <a:off x="747713" y="1388715"/>
+            <a:off x="747713" y="1383953"/>
             <a:ext cx="11291888" cy="684907"/>
           </a:xfrm>
           <a:prstGeom prst="rect">
@@ -12907,18 +12907,18 @@
           </p:nvPr>
         </p:nvGraphicFramePr>
         <p:xfrm>
-          <a:off x="747713" y="2226022"/>
-          <a:ext cx="6366421" cy="914400"/>
+          <a:off x="747713" y="2221260"/>
+          <a:ext cx="6542633" cy="914400"/>
         </p:xfrm>
         <a:graphic>
           <a:graphicData uri="http://schemas.openxmlformats.org/drawingml/2006/table">
             <a:tbl>
               <a:tblPr/>
               <a:tblGrid>
-                <a:gridCol w="850106"/>
-                <a:gridCol w="1500188"/>
-                <a:gridCol w="2820353"/>
-                <a:gridCol w="1500188"/>
+                <a:gridCol w="900113"/>
+                <a:gridCol w="1530191"/>
+                <a:gridCol w="2890361"/>
+                <a:gridCol w="1550194"/>
               </a:tblGrid>
               <a:tr h="0">
                 <a:tc>
@@ -14574,8 +14574,8 @@
         </p:nvSpPr>
         <p:spPr>
           <a:xfrm>
-            <a:off x="747713" y="957709"/>
-            <a:ext cx="11291888" cy="684907"/>
+            <a:off x="747713" y="747713"/>
+            <a:ext cx="11291888" cy="1237357"/>
           </a:xfrm>
           <a:prstGeom prst="rect">
             <a:avLst/>
@@ -14616,7 +14616,7 @@
         </p:nvSpPr>
         <p:spPr>
           <a:xfrm>
-            <a:off x="747713" y="1795016"/>
+            <a:off x="747713" y="2137470"/>
             <a:ext cx="10696575" cy="4105275"/>
           </a:xfrm>
           <a:prstGeom prst="roundRect">
@@ -14643,7 +14643,7 @@
         </p:nvSpPr>
         <p:spPr>
           <a:xfrm>
-            <a:off x="747713" y="1795016"/>
+            <a:off x="747713" y="2137470"/>
             <a:ext cx="11077575" cy="4105275"/>
           </a:xfrm>
           <a:prstGeom prst="rect">
@@ -15669,8 +15669,8 @@
         </p:nvSpPr>
         <p:spPr>
           <a:xfrm>
-            <a:off x="747713" y="1335732"/>
-            <a:ext cx="11291888" cy="684907"/>
+            <a:off x="747713" y="1054745"/>
+            <a:ext cx="11291888" cy="1237357"/>
           </a:xfrm>
           <a:prstGeom prst="rect">
             <a:avLst/>
@@ -15711,7 +15711,7 @@
         </p:nvSpPr>
         <p:spPr>
           <a:xfrm>
-            <a:off x="747713" y="2401639"/>
+            <a:off x="747713" y="2673102"/>
             <a:ext cx="6326386" cy="379809"/>
           </a:xfrm>
           <a:prstGeom prst="rect">
@@ -15753,8 +15753,8 @@
         </p:nvSpPr>
         <p:spPr>
           <a:xfrm>
-            <a:off x="747713" y="2933849"/>
-            <a:ext cx="6326386" cy="1869132"/>
+            <a:off x="747713" y="3205311"/>
+            <a:ext cx="6326386" cy="1878657"/>
           </a:xfrm>
           <a:prstGeom prst="rect">
             <a:avLst/>
@@ -15880,7 +15880,7 @@
         </p:nvSpPr>
         <p:spPr>
           <a:xfrm>
-            <a:off x="747713" y="4955381"/>
+            <a:off x="747713" y="5236369"/>
             <a:ext cx="6326386" cy="414338"/>
           </a:xfrm>
           <a:prstGeom prst="rect">
@@ -15922,7 +15922,7 @@
         </p:nvSpPr>
         <p:spPr>
           <a:xfrm>
-            <a:off x="7226498" y="2173039"/>
+            <a:off x="7226498" y="2444502"/>
             <a:ext cx="4217789" cy="661988"/>
           </a:xfrm>
           <a:prstGeom prst="roundRect">
@@ -16716,7 +16716,7 @@
         </p:nvSpPr>
         <p:spPr>
           <a:xfrm>
-            <a:off x="747713" y="1948458"/>
+            <a:off x="747713" y="1938933"/>
             <a:ext cx="11291888" cy="684907"/>
           </a:xfrm>
           <a:prstGeom prst="rect">
@@ -16758,8 +16758,8 @@
         </p:nvSpPr>
         <p:spPr>
           <a:xfrm>
-            <a:off x="747713" y="2785765"/>
-            <a:ext cx="11001375" cy="418951"/>
+            <a:off x="747713" y="2776240"/>
+            <a:ext cx="11001375" cy="428476"/>
           </a:xfrm>
           <a:prstGeom prst="rect">
             <a:avLst/>
@@ -17150,7 +17150,7 @@
         <p:spPr>
           <a:xfrm>
             <a:off x="747713" y="4490591"/>
-            <a:ext cx="11001375" cy="418951"/>
+            <a:ext cx="11001375" cy="428476"/>
           </a:xfrm>
           <a:prstGeom prst="rect">
             <a:avLst/>
@@ -18336,7 +18336,7 @@
         <p:spPr>
           <a:xfrm>
             <a:off x="747713" y="2922538"/>
-            <a:ext cx="11001375" cy="418951"/>
+            <a:ext cx="11001375" cy="428476"/>
           </a:xfrm>
           <a:prstGeom prst="rect">
             <a:avLst/>
@@ -18489,7 +18489,7 @@
         </p:nvSpPr>
         <p:spPr>
           <a:xfrm>
-            <a:off x="747713" y="3493889"/>
+            <a:off x="747713" y="3503414"/>
             <a:ext cx="5291138" cy="3294459"/>
           </a:xfrm>
           <a:prstGeom prst="roundRect">
@@ -18513,7 +18513,7 @@
         </p:nvSpPr>
         <p:spPr>
           <a:xfrm>
-            <a:off x="871538" y="3846314"/>
+            <a:off x="871538" y="3855839"/>
             <a:ext cx="5043488" cy="379809"/>
           </a:xfrm>
           <a:prstGeom prst="rect">
@@ -18572,7 +18572,7 @@
         </p:nvSpPr>
         <p:spPr>
           <a:xfrm>
-            <a:off x="871538" y="4378523"/>
+            <a:off x="871538" y="4388048"/>
             <a:ext cx="5043488" cy="1381125"/>
           </a:xfrm>
           <a:prstGeom prst="rect">
@@ -18711,7 +18711,7 @@
         </p:nvSpPr>
         <p:spPr>
           <a:xfrm>
-            <a:off x="871538" y="5912048"/>
+            <a:off x="871538" y="5921573"/>
             <a:ext cx="5043488" cy="600075"/>
           </a:xfrm>
           <a:prstGeom prst="roundRect">
@@ -18738,7 +18738,7 @@
         </p:nvSpPr>
         <p:spPr>
           <a:xfrm>
-            <a:off x="871538" y="5912048"/>
+            <a:off x="871538" y="5921573"/>
             <a:ext cx="5119688" cy="600075"/>
           </a:xfrm>
           <a:prstGeom prst="rect">
@@ -18821,16 +18821,16 @@
           </p:nvPr>
         </p:nvGraphicFramePr>
         <p:xfrm>
-          <a:off x="6153150" y="3493889"/>
-          <a:ext cx="1845618" cy="914400"/>
+          <a:off x="6153150" y="3503414"/>
+          <a:ext cx="1884908" cy="914400"/>
         </p:xfrm>
         <a:graphic>
           <a:graphicData uri="http://schemas.openxmlformats.org/drawingml/2006/table">
             <a:tbl>
               <a:tblPr/>
               <a:tblGrid>
-                <a:gridCol w="970121"/>
-                <a:gridCol w="950119"/>
+                <a:gridCol w="990124"/>
+                <a:gridCol w="980123"/>
               </a:tblGrid>
               <a:tr h="0">
                 <a:tc>
@@ -19234,7 +19234,7 @@
         </p:nvSpPr>
         <p:spPr>
           <a:xfrm>
-            <a:off x="6153150" y="5270302"/>
+            <a:off x="6153150" y="5279827"/>
             <a:ext cx="66675" cy="414338"/>
           </a:xfrm>
           <a:prstGeom prst="rect">
@@ -19254,7 +19254,7 @@
         </p:nvSpPr>
         <p:spPr>
           <a:xfrm>
-            <a:off x="6219825" y="5270302"/>
+            <a:off x="6219825" y="5279827"/>
             <a:ext cx="5224462" cy="414338"/>
           </a:xfrm>
           <a:prstGeom prst="rect">
@@ -20712,8 +20712,8 @@
         </p:nvSpPr>
         <p:spPr>
           <a:xfrm>
-            <a:off x="2591246" y="2742307"/>
-            <a:ext cx="1064121" cy="352425"/>
+            <a:off x="2749302" y="2751832"/>
+            <a:ext cx="1103561" cy="352425"/>
           </a:xfrm>
           <a:prstGeom prst="roundRect">
             <a:avLst>
@@ -20734,8 +20734,8 @@
         </p:nvSpPr>
         <p:spPr>
           <a:xfrm>
-            <a:off x="2591246" y="2742307"/>
-            <a:ext cx="1064121" cy="352425"/>
+            <a:off x="2749302" y="2751832"/>
+            <a:ext cx="1103561" cy="352425"/>
           </a:xfrm>
           <a:prstGeom prst="rect">
             <a:avLst/>
@@ -20776,8 +20776,8 @@
         </p:nvSpPr>
         <p:spPr>
           <a:xfrm>
-            <a:off x="2048173" y="3156645"/>
-            <a:ext cx="1047304" cy="352425"/>
+            <a:off x="2129135" y="3166170"/>
+            <a:ext cx="1106091" cy="352425"/>
           </a:xfrm>
           <a:prstGeom prst="roundRect">
             <a:avLst>
@@ -20798,8 +20798,8 @@
         </p:nvSpPr>
         <p:spPr>
           <a:xfrm>
-            <a:off x="2048173" y="3156645"/>
-            <a:ext cx="1047304" cy="352425"/>
+            <a:off x="2129135" y="3166170"/>
+            <a:ext cx="1106091" cy="352425"/>
           </a:xfrm>
           <a:prstGeom prst="rect">
             <a:avLst/>
@@ -20840,8 +20840,8 @@
         </p:nvSpPr>
         <p:spPr>
           <a:xfrm>
-            <a:off x="2065883" y="3570982"/>
-            <a:ext cx="1392138" cy="352425"/>
+            <a:off x="2146102" y="3580507"/>
+            <a:ext cx="1432620" cy="352425"/>
           </a:xfrm>
           <a:prstGeom prst="roundRect">
             <a:avLst>
@@ -20862,8 +20862,8 @@
         </p:nvSpPr>
         <p:spPr>
           <a:xfrm>
-            <a:off x="2065883" y="3570982"/>
-            <a:ext cx="1392138" cy="352425"/>
+            <a:off x="2146102" y="3580507"/>
+            <a:ext cx="1432620" cy="352425"/>
           </a:xfrm>
           <a:prstGeom prst="rect">
             <a:avLst/>
@@ -21058,7 +21058,7 @@
         <p:spPr>
           <a:xfrm>
             <a:off x="747713" y="4666357"/>
-            <a:ext cx="1002804" cy="490538"/>
+            <a:ext cx="1015157" cy="490538"/>
           </a:xfrm>
           <a:prstGeom prst="roundRect">
             <a:avLst>
@@ -21080,7 +21080,7 @@
         <p:spPr>
           <a:xfrm>
             <a:off x="747713" y="4666357"/>
-            <a:ext cx="1002804" cy="490538"/>
+            <a:ext cx="1015157" cy="490538"/>
           </a:xfrm>
           <a:prstGeom prst="rect">
             <a:avLst/>
@@ -21121,8 +21121,8 @@
         </p:nvSpPr>
         <p:spPr>
           <a:xfrm>
-            <a:off x="1788616" y="4666357"/>
-            <a:ext cx="1055638" cy="490538"/>
+            <a:off x="1800969" y="4666357"/>
+            <a:ext cx="1064270" cy="490538"/>
           </a:xfrm>
           <a:prstGeom prst="roundRect">
             <a:avLst>
@@ -21143,8 +21143,8 @@
         </p:nvSpPr>
         <p:spPr>
           <a:xfrm>
-            <a:off x="1788616" y="4666357"/>
-            <a:ext cx="1055638" cy="490538"/>
+            <a:off x="1800969" y="4666357"/>
+            <a:ext cx="1064270" cy="490538"/>
           </a:xfrm>
           <a:prstGeom prst="rect">
             <a:avLst/>
@@ -21185,8 +21185,8 @@
         </p:nvSpPr>
         <p:spPr>
           <a:xfrm>
-            <a:off x="2882354" y="4666357"/>
-            <a:ext cx="932408" cy="490538"/>
+            <a:off x="2903339" y="4666357"/>
+            <a:ext cx="959793" cy="490538"/>
           </a:xfrm>
           <a:prstGeom prst="roundRect">
             <a:avLst>
@@ -21207,8 +21207,8 @@
         </p:nvSpPr>
         <p:spPr>
           <a:xfrm>
-            <a:off x="2882354" y="4666357"/>
-            <a:ext cx="932408" cy="490538"/>
+            <a:off x="2903339" y="4666357"/>
+            <a:ext cx="959793" cy="490538"/>
           </a:xfrm>
           <a:prstGeom prst="rect">
             <a:avLst/>
@@ -21355,7 +21355,7 @@
         </p:nvSpPr>
         <p:spPr>
           <a:xfrm>
-            <a:off x="2020639" y="5949851"/>
+            <a:off x="2039243" y="5949851"/>
             <a:ext cx="266700" cy="266700"/>
           </a:xfrm>
           <a:prstGeom prst="roundRect">
@@ -21377,7 +21377,7 @@
         </p:nvSpPr>
         <p:spPr>
           <a:xfrm>
-            <a:off x="4363938" y="5918895"/>
+            <a:off x="4511576" y="5918895"/>
             <a:ext cx="266700" cy="266700"/>
           </a:xfrm>
           <a:prstGeom prst="roundRect">
@@ -22041,12 +22041,12 @@
         </p:nvSpPr>
         <p:spPr>
           <a:xfrm>
-            <a:off x="2112615" y="4602659"/>
-            <a:ext cx="962471" cy="314325"/>
+            <a:off x="2153245" y="4602659"/>
+            <a:ext cx="999976" cy="323850"/>
           </a:xfrm>
           <a:prstGeom prst="roundRect">
             <a:avLst>
-              <a:gd name="adj" fmla="val 141047"/>
+              <a:gd name="adj" fmla="val 132872"/>
             </a:avLst>
           </a:prstGeom>
           <a:solidFill>
@@ -22063,8 +22063,8 @@
         </p:nvSpPr>
         <p:spPr>
           <a:xfrm>
-            <a:off x="2112615" y="4602659"/>
-            <a:ext cx="962471" cy="314325"/>
+            <a:off x="2153245" y="4602659"/>
+            <a:ext cx="999976" cy="323850"/>
           </a:xfrm>
           <a:prstGeom prst="rect">
             <a:avLst/>
@@ -22375,7 +22375,7 @@
         <p:spPr>
           <a:xfrm>
             <a:off x="747713" y="3369022"/>
-            <a:ext cx="4986635" cy="857250"/>
+            <a:ext cx="4922490" cy="857250"/>
           </a:xfrm>
           <a:prstGeom prst="rect">
             <a:avLst/>
@@ -22467,7 +22467,7 @@
         </p:nvSpPr>
         <p:spPr>
           <a:xfrm>
-            <a:off x="747713" y="1593503"/>
+            <a:off x="747713" y="1707803"/>
             <a:ext cx="11291888" cy="684907"/>
           </a:xfrm>
           <a:prstGeom prst="rect">
@@ -22523,8 +22523,8 @@
         </p:blipFill>
         <p:spPr>
           <a:xfrm>
-            <a:off x="747713" y="2430810"/>
-            <a:ext cx="4286250" cy="2733675"/>
+            <a:off x="747713" y="2545110"/>
+            <a:ext cx="4286250" cy="2505075"/>
           </a:xfrm>
           <a:prstGeom prst="rect">
             <a:avLst/>
@@ -22616,7 +22616,7 @@
         </p:nvSpPr>
         <p:spPr>
           <a:xfrm>
-            <a:off x="747713" y="1033909"/>
+            <a:off x="747713" y="1148209"/>
             <a:ext cx="11291888" cy="1237357"/>
           </a:xfrm>
           <a:prstGeom prst="rect">
@@ -22658,7 +22658,7 @@
         </p:nvSpPr>
         <p:spPr>
           <a:xfrm>
-            <a:off x="747713" y="2423666"/>
+            <a:off x="747713" y="2537966"/>
             <a:ext cx="5272088" cy="414338"/>
           </a:xfrm>
           <a:prstGeom prst="rect">
@@ -22708,8 +22708,8 @@
         </p:blipFill>
         <p:spPr>
           <a:xfrm>
-            <a:off x="747713" y="2990404"/>
-            <a:ext cx="2874020" cy="523875"/>
+            <a:off x="747713" y="3104704"/>
+            <a:ext cx="2939802" cy="523875"/>
           </a:xfrm>
           <a:prstGeom prst="rect">
             <a:avLst/>
@@ -22724,7 +22724,7 @@
         </p:nvSpPr>
         <p:spPr>
           <a:xfrm>
-            <a:off x="6172200" y="2423666"/>
+            <a:off x="6172200" y="2537966"/>
             <a:ext cx="5576888" cy="414338"/>
           </a:xfrm>
           <a:prstGeom prst="rect">
@@ -22780,8 +22780,8 @@
         </p:blipFill>
         <p:spPr>
           <a:xfrm>
-            <a:off x="6172200" y="2990404"/>
-            <a:ext cx="4286250" cy="2733675"/>
+            <a:off x="6172200" y="3104704"/>
+            <a:ext cx="4286250" cy="2505075"/>
           </a:xfrm>
           <a:prstGeom prst="rect">
             <a:avLst/>
@@ -23837,7 +23837,7 @@
         </p:nvSpPr>
         <p:spPr>
           <a:xfrm>
-            <a:off x="747713" y="1748433"/>
+            <a:off x="747713" y="1738908"/>
             <a:ext cx="11291888" cy="1237357"/>
           </a:xfrm>
           <a:prstGeom prst="rect">
@@ -23879,7 +23879,7 @@
         </p:nvSpPr>
         <p:spPr>
           <a:xfrm>
-            <a:off x="747713" y="3138190"/>
+            <a:off x="747713" y="3128665"/>
             <a:ext cx="11001375" cy="414338"/>
           </a:xfrm>
           <a:prstGeom prst="rect">
@@ -23921,8 +23921,8 @@
         </p:nvSpPr>
         <p:spPr>
           <a:xfrm>
-            <a:off x="747713" y="3704927"/>
-            <a:ext cx="11001375" cy="833289"/>
+            <a:off x="747713" y="3695402"/>
+            <a:ext cx="11001375" cy="842814"/>
           </a:xfrm>
           <a:prstGeom prst="rect">
             <a:avLst/>
@@ -24038,7 +24038,7 @@
         <p:spPr>
           <a:xfrm>
             <a:off x="747713" y="4690616"/>
-            <a:ext cx="11001375" cy="418951"/>
+            <a:ext cx="11001375" cy="428476"/>
           </a:xfrm>
           <a:prstGeom prst="rect">
             <a:avLst/>
@@ -24217,8 +24217,8 @@
         </p:nvSpPr>
         <p:spPr>
           <a:xfrm>
-            <a:off x="747713" y="1432024"/>
-            <a:ext cx="11291888" cy="684907"/>
+            <a:off x="747713" y="1146274"/>
+            <a:ext cx="11291888" cy="1237357"/>
           </a:xfrm>
           <a:prstGeom prst="rect">
             <a:avLst/>
@@ -24259,7 +24259,7 @@
         </p:nvSpPr>
         <p:spPr>
           <a:xfrm>
-            <a:off x="747713" y="2345531"/>
+            <a:off x="747713" y="2612231"/>
             <a:ext cx="47625" cy="556468"/>
           </a:xfrm>
           <a:prstGeom prst="rect">
@@ -24284,7 +24284,7 @@
         </p:nvSpPr>
         <p:spPr>
           <a:xfrm>
-            <a:off x="795338" y="2345531"/>
+            <a:off x="795338" y="2612231"/>
             <a:ext cx="11244263" cy="556468"/>
           </a:xfrm>
           <a:prstGeom prst="rect">
@@ -24326,8 +24326,8 @@
         </p:nvSpPr>
         <p:spPr>
           <a:xfrm>
-            <a:off x="747713" y="3054400"/>
-            <a:ext cx="11001375" cy="837902"/>
+            <a:off x="747713" y="3321100"/>
+            <a:ext cx="11001375" cy="856952"/>
           </a:xfrm>
           <a:prstGeom prst="rect">
             <a:avLst/>
@@ -24442,7 +24442,7 @@
         </p:nvSpPr>
         <p:spPr>
           <a:xfrm>
-            <a:off x="747713" y="4044702"/>
+            <a:off x="747713" y="4330452"/>
             <a:ext cx="10696575" cy="1381125"/>
           </a:xfrm>
           <a:prstGeom prst="rect">
@@ -24604,7 +24604,7 @@
         </p:nvSpPr>
         <p:spPr>
           <a:xfrm>
-            <a:off x="747713" y="2231827"/>
+            <a:off x="747713" y="2222302"/>
             <a:ext cx="11291888" cy="684907"/>
           </a:xfrm>
           <a:prstGeom prst="rect">
@@ -24646,8 +24646,8 @@
         </p:nvSpPr>
         <p:spPr>
           <a:xfrm>
-            <a:off x="747713" y="3069134"/>
-            <a:ext cx="11001375" cy="837902"/>
+            <a:off x="747713" y="3059609"/>
+            <a:ext cx="11001375" cy="856952"/>
           </a:xfrm>
           <a:prstGeom prst="rect">
             <a:avLst/>
@@ -24762,7 +24762,7 @@
         </p:nvSpPr>
         <p:spPr>
           <a:xfrm>
-            <a:off x="747713" y="4059436"/>
+            <a:off x="747713" y="4068961"/>
             <a:ext cx="11001375" cy="414338"/>
           </a:xfrm>
           <a:prstGeom prst="rect">
@@ -25447,18 +25447,18 @@
         </p:nvGraphicFramePr>
         <p:xfrm>
           <a:off x="747713" y="2493615"/>
-          <a:ext cx="4758779" cy="914400"/>
+          <a:ext cx="5009257" cy="914400"/>
         </p:xfrm>
         <a:graphic>
           <a:graphicData uri="http://schemas.openxmlformats.org/drawingml/2006/table">
             <a:tbl>
               <a:tblPr/>
               <a:tblGrid>
-                <a:gridCol w="890111"/>
-                <a:gridCol w="1100138"/>
-                <a:gridCol w="1090136"/>
-                <a:gridCol w="1090136"/>
-                <a:gridCol w="820103"/>
+                <a:gridCol w="920115"/>
+                <a:gridCol w="1160145"/>
+                <a:gridCol w="1150144"/>
+                <a:gridCol w="1150144"/>
+                <a:gridCol w="880110"/>
               </a:tblGrid>
               <a:tr h="0">
                 <a:tc>
@@ -27201,7 +27201,7 @@
         </p:nvSpPr>
         <p:spPr>
           <a:xfrm>
-            <a:off x="747713" y="1824484"/>
+            <a:off x="747713" y="1821507"/>
             <a:ext cx="11291888" cy="684907"/>
           </a:xfrm>
           <a:prstGeom prst="rect">
@@ -27243,8 +27243,8 @@
         </p:nvSpPr>
         <p:spPr>
           <a:xfrm>
-            <a:off x="9069437" y="2661791"/>
-            <a:ext cx="2374850" cy="404813"/>
+            <a:off x="8944570" y="2658814"/>
+            <a:ext cx="2499717" cy="404813"/>
           </a:xfrm>
           <a:prstGeom prst="roundRect">
             <a:avLst>
@@ -27270,8 +27270,8 @@
         </p:nvSpPr>
         <p:spPr>
           <a:xfrm>
-            <a:off x="9069437" y="2661791"/>
-            <a:ext cx="2451050" cy="404813"/>
+            <a:off x="8944570" y="2658814"/>
+            <a:ext cx="2575917" cy="404813"/>
           </a:xfrm>
           <a:prstGeom prst="rect">
             <a:avLst/>
@@ -27312,8 +27312,8 @@
         </p:nvSpPr>
         <p:spPr>
           <a:xfrm>
-            <a:off x="747713" y="3161854"/>
-            <a:ext cx="2181820" cy="852488"/>
+            <a:off x="747713" y="3158877"/>
+            <a:ext cx="2298353" cy="852488"/>
           </a:xfrm>
           <a:prstGeom prst="roundRect">
             <a:avLst>
@@ -27339,8 +27339,8 @@
         </p:nvSpPr>
         <p:spPr>
           <a:xfrm>
-            <a:off x="747713" y="3161854"/>
-            <a:ext cx="2258020" cy="852488"/>
+            <a:off x="747713" y="3158877"/>
+            <a:ext cx="2374553" cy="852488"/>
           </a:xfrm>
           <a:prstGeom prst="rect">
             <a:avLst/>
@@ -27467,8 +27467,8 @@
         </p:nvSpPr>
         <p:spPr>
           <a:xfrm>
-            <a:off x="9367391" y="4109591"/>
-            <a:ext cx="2076896" cy="404813"/>
+            <a:off x="9267379" y="4106614"/>
+            <a:ext cx="2176909" cy="404813"/>
           </a:xfrm>
           <a:prstGeom prst="roundRect">
             <a:avLst>
@@ -27494,8 +27494,8 @@
         </p:nvSpPr>
         <p:spPr>
           <a:xfrm>
-            <a:off x="9367391" y="4109591"/>
-            <a:ext cx="2153096" cy="404813"/>
+            <a:off x="9267379" y="4106614"/>
+            <a:ext cx="2253109" cy="404813"/>
           </a:xfrm>
           <a:prstGeom prst="rect">
             <a:avLst/>
@@ -27536,12 +27536,12 @@
         </p:nvSpPr>
         <p:spPr>
           <a:xfrm>
-            <a:off x="747713" y="4609654"/>
-            <a:ext cx="5280868" cy="423863"/>
+            <a:off x="747713" y="4606677"/>
+            <a:ext cx="5599509" cy="429816"/>
           </a:xfrm>
           <a:prstGeom prst="roundRect">
             <a:avLst>
-              <a:gd name="adj" fmla="val 107865"/>
+              <a:gd name="adj" fmla="val 106371"/>
             </a:avLst>
           </a:prstGeom>
           <a:solidFill>
@@ -27563,8 +27563,8 @@
         </p:nvSpPr>
         <p:spPr>
           <a:xfrm>
-            <a:off x="747713" y="4609654"/>
-            <a:ext cx="5357068" cy="423863"/>
+            <a:off x="747713" y="4606677"/>
+            <a:ext cx="5675709" cy="429816"/>
           </a:xfrm>
           <a:prstGeom prst="rect">
             <a:avLst/>
@@ -28258,7 +28258,7 @@
         </p:nvSpPr>
         <p:spPr>
           <a:xfrm>
-            <a:off x="747713" y="2245965"/>
+            <a:off x="747713" y="2242989"/>
             <a:ext cx="11291888" cy="684907"/>
           </a:xfrm>
           <a:prstGeom prst="rect">
@@ -28300,8 +28300,8 @@
         </p:nvSpPr>
         <p:spPr>
           <a:xfrm>
-            <a:off x="747713" y="3083272"/>
-            <a:ext cx="10696575" cy="404813"/>
+            <a:off x="747713" y="3080296"/>
+            <a:ext cx="10696575" cy="410766"/>
           </a:xfrm>
           <a:prstGeom prst="rect">
             <a:avLst/>
@@ -28320,8 +28320,8 @@
         </p:nvSpPr>
         <p:spPr>
           <a:xfrm>
-            <a:off x="747713" y="3083272"/>
-            <a:ext cx="57150" cy="404813"/>
+            <a:off x="747713" y="3080296"/>
+            <a:ext cx="57150" cy="410766"/>
           </a:xfrm>
           <a:prstGeom prst="rect">
             <a:avLst/>
@@ -28345,8 +28345,8 @@
         </p:nvSpPr>
         <p:spPr>
           <a:xfrm>
-            <a:off x="747713" y="3083272"/>
-            <a:ext cx="11077575" cy="404813"/>
+            <a:off x="747713" y="3080296"/>
+            <a:ext cx="11077575" cy="410766"/>
           </a:xfrm>
           <a:prstGeom prst="rect">
             <a:avLst/>
@@ -28475,7 +28475,7 @@
         </p:nvSpPr>
         <p:spPr>
           <a:xfrm>
-            <a:off x="747713" y="3640485"/>
+            <a:off x="747713" y="3643461"/>
             <a:ext cx="11001375" cy="414338"/>
           </a:xfrm>
           <a:prstGeom prst="rect">
@@ -28517,7 +28517,7 @@
         </p:nvSpPr>
         <p:spPr>
           <a:xfrm>
-            <a:off x="747713" y="4207222"/>
+            <a:off x="747713" y="4210199"/>
             <a:ext cx="10696575" cy="404813"/>
           </a:xfrm>
           <a:prstGeom prst="rect">
@@ -28537,7 +28537,7 @@
         </p:nvSpPr>
         <p:spPr>
           <a:xfrm>
-            <a:off x="747713" y="4207222"/>
+            <a:off x="747713" y="4210199"/>
             <a:ext cx="57150" cy="404813"/>
           </a:xfrm>
           <a:prstGeom prst="rect">
@@ -28562,7 +28562,7 @@
         </p:nvSpPr>
         <p:spPr>
           <a:xfrm>
-            <a:off x="747713" y="4207222"/>
+            <a:off x="747713" y="4210199"/>
             <a:ext cx="11077575" cy="404813"/>
           </a:xfrm>
           <a:prstGeom prst="rect">
@@ -28774,8 +28774,8 @@
         </p:nvSpPr>
         <p:spPr>
           <a:xfrm>
-            <a:off x="5185321" y="3026122"/>
-            <a:ext cx="1821359" cy="604838"/>
+            <a:off x="5129510" y="3026122"/>
+            <a:ext cx="1932831" cy="604838"/>
           </a:xfrm>
           <a:prstGeom prst="roundRect">
             <a:avLst>
@@ -28796,8 +28796,8 @@
         </p:nvSpPr>
         <p:spPr>
           <a:xfrm>
-            <a:off x="5185321" y="3026122"/>
-            <a:ext cx="1897559" cy="604838"/>
+            <a:off x="5129510" y="3026122"/>
+            <a:ext cx="2009031" cy="604838"/>
           </a:xfrm>
           <a:prstGeom prst="rect">
             <a:avLst/>
@@ -29376,16 +29376,16 @@
         </p:nvGraphicFramePr>
         <p:xfrm>
           <a:off x="747713" y="3649563"/>
-          <a:ext cx="3720257" cy="914400"/>
+          <a:ext cx="3917603" cy="914400"/>
         </p:xfrm>
         <a:graphic>
           <a:graphicData uri="http://schemas.openxmlformats.org/drawingml/2006/table">
             <a:tbl>
               <a:tblPr/>
               <a:tblGrid>
-                <a:gridCol w="590074"/>
-                <a:gridCol w="1210151"/>
-                <a:gridCol w="2090261"/>
+                <a:gridCol w="620078"/>
+                <a:gridCol w="1280160"/>
+                <a:gridCol w="2200275"/>
               </a:tblGrid>
               <a:tr h="0">
                 <a:tc>
@@ -30811,7 +30811,7 @@
         </p:nvSpPr>
         <p:spPr>
           <a:xfrm>
-            <a:off x="747713" y="2310259"/>
+            <a:off x="747713" y="2305496"/>
             <a:ext cx="11291888" cy="684907"/>
           </a:xfrm>
           <a:prstGeom prst="rect">
@@ -30853,8 +30853,8 @@
         </p:nvSpPr>
         <p:spPr>
           <a:xfrm>
-            <a:off x="747713" y="3147566"/>
-            <a:ext cx="11001375" cy="833289"/>
+            <a:off x="747713" y="3142804"/>
+            <a:ext cx="11001375" cy="842814"/>
           </a:xfrm>
           <a:prstGeom prst="rect">
             <a:avLst/>
@@ -30912,7 +30912,7 @@
         </p:nvSpPr>
         <p:spPr>
           <a:xfrm>
-            <a:off x="747713" y="4133255"/>
+            <a:off x="747713" y="4138017"/>
             <a:ext cx="11001375" cy="414338"/>
           </a:xfrm>
           <a:prstGeom prst="rect">
@@ -31055,7 +31055,7 @@
         </p:nvSpPr>
         <p:spPr>
           <a:xfrm>
-            <a:off x="747713" y="1826865"/>
+            <a:off x="747713" y="1822103"/>
             <a:ext cx="7634288" cy="684907"/>
           </a:xfrm>
           <a:prstGeom prst="rect">
@@ -31097,8 +31097,8 @@
         </p:nvSpPr>
         <p:spPr>
           <a:xfrm>
-            <a:off x="747713" y="2664172"/>
-            <a:ext cx="7343775" cy="833289"/>
+            <a:off x="747713" y="2659410"/>
+            <a:ext cx="7343775" cy="842814"/>
           </a:xfrm>
           <a:prstGeom prst="rect">
             <a:avLst/>
@@ -31159,7 +31159,7 @@
         </p:nvSpPr>
         <p:spPr>
           <a:xfrm>
-            <a:off x="747713" y="3649861"/>
+            <a:off x="747713" y="3654623"/>
             <a:ext cx="7038975" cy="1381125"/>
           </a:xfrm>
           <a:prstGeom prst="rect">
@@ -31760,8 +31760,8 @@
         </p:nvSpPr>
         <p:spPr>
           <a:xfrm>
-            <a:off x="5997327" y="3538091"/>
-            <a:ext cx="349746" cy="342900"/>
+            <a:off x="5981700" y="3538091"/>
+            <a:ext cx="381000" cy="342900"/>
           </a:xfrm>
           <a:prstGeom prst="rect">
             <a:avLst/>
@@ -32359,7 +32359,7 @@
         <p:spPr>
           <a:xfrm>
             <a:off x="0" y="6515100"/>
-            <a:ext cx="246459" cy="342900"/>
+            <a:ext cx="261640" cy="342900"/>
           </a:xfrm>
           <a:prstGeom prst="rect">
             <a:avLst/>
@@ -32378,7 +32378,7 @@
         </p:nvSpPr>
         <p:spPr>
           <a:xfrm>
-            <a:off x="747713" y="2243584"/>
+            <a:off x="747713" y="2036415"/>
             <a:ext cx="11291888" cy="1237357"/>
           </a:xfrm>
           <a:prstGeom prst="rect">
@@ -32420,7 +32420,7 @@
         </p:nvSpPr>
         <p:spPr>
           <a:xfrm>
-            <a:off x="747713" y="3633341"/>
+            <a:off x="747713" y="3426172"/>
             <a:ext cx="11001375" cy="414338"/>
           </a:xfrm>
           <a:prstGeom prst="rect">
@@ -32496,8 +32496,8 @@
         </p:nvSpPr>
         <p:spPr>
           <a:xfrm>
-            <a:off x="747713" y="4200079"/>
-            <a:ext cx="11001375" cy="414338"/>
+            <a:off x="747713" y="3992910"/>
+            <a:ext cx="11001375" cy="828675"/>
           </a:xfrm>
           <a:prstGeom prst="rect">
             <a:avLst/>
@@ -33261,9 +33261,9 @@
             <a:tbl>
               <a:tblPr/>
               <a:tblGrid>
-                <a:gridCol w="830104"/>
-                <a:gridCol w="920115"/>
-                <a:gridCol w="920115"/>
+                <a:gridCol w="870109"/>
+                <a:gridCol w="930116"/>
+                <a:gridCol w="930116"/>
               </a:tblGrid>
               <a:tr h="0">
                 <a:tc>
@@ -35372,7 +35372,7 @@
         </p:nvSpPr>
         <p:spPr>
           <a:xfrm>
-            <a:off x="747713" y="852934"/>
+            <a:off x="747713" y="841177"/>
             <a:ext cx="11291888" cy="1237357"/>
           </a:xfrm>
           <a:prstGeom prst="rect">
@@ -35414,8 +35414,8 @@
         </p:nvSpPr>
         <p:spPr>
           <a:xfrm>
-            <a:off x="747713" y="2242691"/>
-            <a:ext cx="11001375" cy="833289"/>
+            <a:off x="747713" y="2230934"/>
+            <a:ext cx="11001375" cy="856952"/>
           </a:xfrm>
           <a:prstGeom prst="rect">
             <a:avLst/>
@@ -35564,7 +35564,7 @@
         </p:nvSpPr>
         <p:spPr>
           <a:xfrm>
-            <a:off x="747713" y="3228380"/>
+            <a:off x="747713" y="3240286"/>
             <a:ext cx="11001375" cy="1243013"/>
           </a:xfrm>
           <a:prstGeom prst="rect">
@@ -35674,7 +35674,7 @@
         </p:nvSpPr>
         <p:spPr>
           <a:xfrm>
-            <a:off x="747713" y="4623792"/>
+            <a:off x="747713" y="4635698"/>
             <a:ext cx="10696575" cy="1381125"/>
           </a:xfrm>
           <a:prstGeom prst="rect">
@@ -36837,8 +36837,8 @@
         </p:nvSpPr>
         <p:spPr>
           <a:xfrm>
-            <a:off x="747713" y="1558975"/>
-            <a:ext cx="11291888" cy="684907"/>
+            <a:off x="747713" y="1282750"/>
+            <a:ext cx="11291888" cy="1237357"/>
           </a:xfrm>
           <a:prstGeom prst="rect">
             <a:avLst/>
@@ -36879,7 +36879,7 @@
         </p:nvSpPr>
         <p:spPr>
           <a:xfrm>
-            <a:off x="747713" y="2396282"/>
+            <a:off x="747713" y="2672507"/>
             <a:ext cx="10696575" cy="2419350"/>
           </a:xfrm>
           <a:prstGeom prst="rect">
@@ -36930,7 +36930,7 @@
         </p:blipFill>
         <p:spPr>
           <a:xfrm>
-            <a:off x="1300163" y="2810619"/>
+            <a:off x="1300163" y="3086844"/>
             <a:ext cx="1905000" cy="1905000"/>
           </a:xfrm>
           <a:prstGeom prst="rect">
@@ -36946,7 +36946,7 @@
         </p:nvSpPr>
         <p:spPr>
           <a:xfrm>
-            <a:off x="747713" y="4884688"/>
+            <a:off x="747713" y="5160913"/>
             <a:ext cx="10696575" cy="414338"/>
           </a:xfrm>
           <a:prstGeom prst="rect">
@@ -37066,7 +37066,7 @@
         </p:nvSpPr>
         <p:spPr>
           <a:xfrm>
-            <a:off x="747713" y="1824484"/>
+            <a:off x="747713" y="1819721"/>
             <a:ext cx="11291888" cy="1237357"/>
           </a:xfrm>
           <a:prstGeom prst="rect">
@@ -37131,7 +37131,7 @@
         </p:nvSpPr>
         <p:spPr>
           <a:xfrm>
-            <a:off x="747713" y="3261866"/>
+            <a:off x="747713" y="3257104"/>
             <a:ext cx="666750" cy="171450"/>
           </a:xfrm>
           <a:prstGeom prst="rect">
@@ -37173,8 +37173,8 @@
         </p:nvSpPr>
         <p:spPr>
           <a:xfrm>
-            <a:off x="4266009" y="3280916"/>
-            <a:ext cx="456754" cy="204788"/>
+            <a:off x="4460081" y="3285679"/>
+            <a:ext cx="454670" cy="204788"/>
           </a:xfrm>
           <a:prstGeom prst="roundRect">
             <a:avLst>
@@ -37195,8 +37195,8 @@
         </p:nvSpPr>
         <p:spPr>
           <a:xfrm>
-            <a:off x="4266009" y="3280916"/>
-            <a:ext cx="532954" cy="204788"/>
+            <a:off x="4460081" y="3285679"/>
+            <a:ext cx="530870" cy="204788"/>
           </a:xfrm>
           <a:prstGeom prst="rect">
             <a:avLst/>
@@ -37237,8 +37237,8 @@
         </p:nvSpPr>
         <p:spPr>
           <a:xfrm>
-            <a:off x="1338263" y="3261866"/>
-            <a:ext cx="3384500" cy="228600"/>
+            <a:off x="1338263" y="3257104"/>
+            <a:ext cx="3576489" cy="233362"/>
           </a:xfrm>
           <a:prstGeom prst="rect">
             <a:avLst/>
@@ -37313,7 +37313,7 @@
         </p:nvSpPr>
         <p:spPr>
           <a:xfrm>
-            <a:off x="747713" y="3880991"/>
+            <a:off x="747713" y="3885754"/>
             <a:ext cx="10696575" cy="9525"/>
           </a:xfrm>
           <a:prstGeom prst="rect">
@@ -37378,8 +37378,8 @@
         </p:nvSpPr>
         <p:spPr>
           <a:xfrm>
-            <a:off x="3330476" y="3614291"/>
-            <a:ext cx="449163" cy="204788"/>
+            <a:off x="3472309" y="3623816"/>
+            <a:ext cx="452438" cy="204788"/>
           </a:xfrm>
           <a:prstGeom prst="roundRect">
             <a:avLst>
@@ -37400,8 +37400,8 @@
         </p:nvSpPr>
         <p:spPr>
           <a:xfrm>
-            <a:off x="3330476" y="3614291"/>
-            <a:ext cx="525363" cy="204788"/>
+            <a:off x="3472309" y="3623816"/>
+            <a:ext cx="528638" cy="204788"/>
           </a:xfrm>
           <a:prstGeom prst="rect">
             <a:avLst/>
@@ -37443,7 +37443,7 @@
         <p:spPr>
           <a:xfrm>
             <a:off x="1338263" y="3595241"/>
-            <a:ext cx="2441377" cy="228600"/>
+            <a:ext cx="2586484" cy="233362"/>
           </a:xfrm>
           <a:prstGeom prst="rect">
             <a:avLst/>
@@ -37518,7 +37518,7 @@
         </p:nvSpPr>
         <p:spPr>
           <a:xfrm>
-            <a:off x="747713" y="3928616"/>
+            <a:off x="747713" y="3933379"/>
             <a:ext cx="666750" cy="171450"/>
           </a:xfrm>
           <a:prstGeom prst="rect">
@@ -37560,8 +37560,8 @@
         </p:nvSpPr>
         <p:spPr>
           <a:xfrm>
-            <a:off x="1338263" y="3928616"/>
-            <a:ext cx="2761506" cy="228600"/>
+            <a:off x="1338263" y="3933379"/>
+            <a:ext cx="2933551" cy="228600"/>
           </a:xfrm>
           <a:prstGeom prst="rect">
             <a:avLst/>
@@ -37636,7 +37636,7 @@
         </p:nvSpPr>
         <p:spPr>
           <a:xfrm>
-            <a:off x="747713" y="4204841"/>
+            <a:off x="747713" y="4209604"/>
             <a:ext cx="11001375" cy="828675"/>
           </a:xfrm>
           <a:prstGeom prst="rect">
@@ -37863,10 +37863,10 @@
               <a:tblPr/>
               <a:tblGrid>
                 <a:gridCol w="420053"/>
+                <a:gridCol w="490061"/>
+                <a:gridCol w="410051"/>
                 <a:gridCol w="470059"/>
-                <a:gridCol w="420053"/>
-                <a:gridCol w="460058"/>
-                <a:gridCol w="460058"/>
+                <a:gridCol w="490061"/>
               </a:tblGrid>
               <a:tr h="0">
                 <a:tc>
@@ -39852,10 +39852,10 @@
               <a:tblPr/>
               <a:tblGrid>
                 <a:gridCol w="420053"/>
-                <a:gridCol w="540068"/>
-                <a:gridCol w="420053"/>
-                <a:gridCol w="460058"/>
-                <a:gridCol w="460058"/>
+                <a:gridCol w="570071"/>
+                <a:gridCol w="410051"/>
+                <a:gridCol w="470059"/>
+                <a:gridCol w="490061"/>
               </a:tblGrid>
               <a:tr h="0">
                 <a:tc>
@@ -42117,8 +42117,8 @@
         </p:nvSpPr>
         <p:spPr>
           <a:xfrm>
-            <a:off x="2519660" y="3294311"/>
-            <a:ext cx="437704" cy="179487"/>
+            <a:off x="2603450" y="3294311"/>
+            <a:ext cx="435620" cy="179487"/>
           </a:xfrm>
           <a:prstGeom prst="roundRect">
             <a:avLst>
@@ -42139,8 +42139,8 @@
         </p:nvSpPr>
         <p:spPr>
           <a:xfrm>
-            <a:off x="2519660" y="3294311"/>
-            <a:ext cx="513904" cy="179487"/>
+            <a:off x="2603450" y="3294311"/>
+            <a:ext cx="511820" cy="179487"/>
           </a:xfrm>
           <a:prstGeom prst="rect">
             <a:avLst/>
@@ -42182,7 +42182,7 @@
         <p:spPr>
           <a:xfrm>
             <a:off x="1157288" y="3294311"/>
-            <a:ext cx="1800076" cy="179487"/>
+            <a:ext cx="1881783" cy="179487"/>
           </a:xfrm>
           <a:prstGeom prst="rect">
             <a:avLst/>
@@ -42287,8 +42287,8 @@
         </p:nvSpPr>
         <p:spPr>
           <a:xfrm>
-            <a:off x="2591991" y="3541961"/>
-            <a:ext cx="430113" cy="179487"/>
+            <a:off x="2689622" y="3541961"/>
+            <a:ext cx="433388" cy="179487"/>
           </a:xfrm>
           <a:prstGeom prst="roundRect">
             <a:avLst>
@@ -42309,8 +42309,8 @@
         </p:nvSpPr>
         <p:spPr>
           <a:xfrm>
-            <a:off x="2591991" y="3541961"/>
-            <a:ext cx="506313" cy="179487"/>
+            <a:off x="2689622" y="3541961"/>
+            <a:ext cx="509587" cy="179487"/>
           </a:xfrm>
           <a:prstGeom prst="rect">
             <a:avLst/>
@@ -42352,7 +42352,7 @@
         <p:spPr>
           <a:xfrm>
             <a:off x="1157288" y="3541961"/>
-            <a:ext cx="1864816" cy="179487"/>
+            <a:ext cx="1965722" cy="179487"/>
           </a:xfrm>
           <a:prstGeom prst="rect">
             <a:avLst/>
@@ -42457,8 +42457,8 @@
         </p:nvSpPr>
         <p:spPr>
           <a:xfrm>
-            <a:off x="2194322" y="3789611"/>
-            <a:ext cx="428030" cy="179487"/>
+            <a:off x="2260253" y="3789611"/>
+            <a:ext cx="429071" cy="179487"/>
           </a:xfrm>
           <a:prstGeom prst="roundRect">
             <a:avLst>
@@ -42479,8 +42479,8 @@
         </p:nvSpPr>
         <p:spPr>
           <a:xfrm>
-            <a:off x="2194322" y="3789611"/>
-            <a:ext cx="504230" cy="179487"/>
+            <a:off x="2260253" y="3789611"/>
+            <a:ext cx="505271" cy="179487"/>
           </a:xfrm>
           <a:prstGeom prst="rect">
             <a:avLst/>
@@ -42522,7 +42522,7 @@
         <p:spPr>
           <a:xfrm>
             <a:off x="1157288" y="3789611"/>
-            <a:ext cx="1465064" cy="179487"/>
+            <a:ext cx="1532037" cy="179487"/>
           </a:xfrm>
           <a:prstGeom prst="rect">
             <a:avLst/>
@@ -42719,7 +42719,7 @@
         <p:spPr>
           <a:xfrm>
             <a:off x="6581775" y="3294311"/>
-            <a:ext cx="1172319" cy="179487"/>
+            <a:ext cx="1244203" cy="179487"/>
           </a:xfrm>
           <a:prstGeom prst="rect">
             <a:avLst/>
@@ -42824,8 +42824,8 @@
         </p:nvSpPr>
         <p:spPr>
           <a:xfrm>
-            <a:off x="7543949" y="3541961"/>
-            <a:ext cx="442020" cy="179487"/>
+            <a:off x="7599908" y="3541961"/>
+            <a:ext cx="441722" cy="179487"/>
           </a:xfrm>
           <a:prstGeom prst="roundRect">
             <a:avLst>
@@ -42846,8 +42846,8 @@
         </p:nvSpPr>
         <p:spPr>
           <a:xfrm>
-            <a:off x="7543949" y="3541961"/>
-            <a:ext cx="518220" cy="179487"/>
+            <a:off x="7599908" y="3541961"/>
+            <a:ext cx="517922" cy="179487"/>
           </a:xfrm>
           <a:prstGeom prst="rect">
             <a:avLst/>
@@ -42889,7 +42889,7 @@
         <p:spPr>
           <a:xfrm>
             <a:off x="6581775" y="3541961"/>
-            <a:ext cx="1404193" cy="179487"/>
+            <a:ext cx="1459855" cy="179487"/>
           </a:xfrm>
           <a:prstGeom prst="rect">
             <a:avLst/>
@@ -42994,8 +42994,8 @@
         </p:nvSpPr>
         <p:spPr>
           <a:xfrm>
-            <a:off x="7468791" y="3789611"/>
-            <a:ext cx="416570" cy="179487"/>
+            <a:off x="7531150" y="3789611"/>
+            <a:ext cx="419546" cy="179487"/>
           </a:xfrm>
           <a:prstGeom prst="roundRect">
             <a:avLst>
@@ -43016,8 +43016,8 @@
         </p:nvSpPr>
         <p:spPr>
           <a:xfrm>
-            <a:off x="7468791" y="3789611"/>
-            <a:ext cx="492770" cy="179487"/>
+            <a:off x="7531150" y="3789611"/>
+            <a:ext cx="495746" cy="179487"/>
           </a:xfrm>
           <a:prstGeom prst="rect">
             <a:avLst/>
@@ -43059,7 +43059,7 @@
         <p:spPr>
           <a:xfrm>
             <a:off x="6581775" y="3789611"/>
-            <a:ext cx="1303586" cy="179487"/>
+            <a:ext cx="1368921" cy="179487"/>
           </a:xfrm>
           <a:prstGeom prst="rect">
             <a:avLst/>
@@ -43337,7 +43337,7 @@
         <p:spPr>
           <a:xfrm>
             <a:off x="1138238" y="3121372"/>
-            <a:ext cx="9389864" cy="400050"/>
+            <a:ext cx="9371558" cy="400050"/>
           </a:xfrm>
           <a:prstGeom prst="rect">
             <a:avLst/>
@@ -43404,8 +43404,8 @@
         </p:nvSpPr>
         <p:spPr>
           <a:xfrm>
-            <a:off x="10166152" y="3164235"/>
-            <a:ext cx="1248787" cy="314325"/>
+            <a:off x="10147846" y="3164235"/>
+            <a:ext cx="1268923" cy="314325"/>
           </a:xfrm>
           <a:prstGeom prst="rect">
             <a:avLst/>
@@ -43489,7 +43489,7 @@
         <p:spPr>
           <a:xfrm>
             <a:off x="890588" y="3702397"/>
-            <a:ext cx="347811" cy="414338"/>
+            <a:ext cx="310455" cy="414338"/>
           </a:xfrm>
           <a:prstGeom prst="rect">
             <a:avLst/>
@@ -43530,8 +43530,8 @@
         </p:nvSpPr>
         <p:spPr>
           <a:xfrm>
-            <a:off x="1181249" y="3809554"/>
-            <a:ext cx="8875216" cy="200025"/>
+            <a:off x="1143893" y="3809554"/>
+            <a:ext cx="8900666" cy="200025"/>
           </a:xfrm>
           <a:prstGeom prst="rect">
             <a:avLst/>
@@ -43572,8 +43572,8 @@
         </p:nvSpPr>
         <p:spPr>
           <a:xfrm>
-            <a:off x="9694515" y="3752404"/>
-            <a:ext cx="1740247" cy="314325"/>
+            <a:off x="9682609" y="3752404"/>
+            <a:ext cx="1752154" cy="314325"/>
           </a:xfrm>
           <a:prstGeom prst="rect">
             <a:avLst/>
@@ -43652,7 +43652,7 @@
         <p:spPr>
           <a:xfrm>
             <a:off x="890588" y="4297710"/>
-            <a:ext cx="347811" cy="414338"/>
+            <a:ext cx="310455" cy="414338"/>
           </a:xfrm>
           <a:prstGeom prst="rect">
             <a:avLst/>
@@ -43693,8 +43693,8 @@
         </p:nvSpPr>
         <p:spPr>
           <a:xfrm>
-            <a:off x="1181249" y="4404866"/>
-            <a:ext cx="8392120" cy="200025"/>
+            <a:off x="1143893" y="4404866"/>
+            <a:ext cx="8404622" cy="200025"/>
           </a:xfrm>
           <a:prstGeom prst="rect">
             <a:avLst/>
@@ -43735,8 +43735,8 @@
         </p:nvSpPr>
         <p:spPr>
           <a:xfrm>
-            <a:off x="9211419" y="4347716"/>
-            <a:ext cx="2223343" cy="314325"/>
+            <a:off x="9186565" y="4347716"/>
+            <a:ext cx="2248198" cy="314325"/>
           </a:xfrm>
           <a:prstGeom prst="rect">
             <a:avLst/>
@@ -43913,7 +43913,7 @@
         </p:nvSpPr>
         <p:spPr>
           <a:xfrm>
-            <a:off x="747713" y="1657796"/>
+            <a:off x="747713" y="1238696"/>
             <a:ext cx="11291888" cy="684907"/>
           </a:xfrm>
           <a:prstGeom prst="rect">
@@ -43962,17 +43962,17 @@
           </p:nvPr>
         </p:nvGraphicFramePr>
         <p:xfrm>
-          <a:off x="747713" y="2495104"/>
-          <a:ext cx="10355312" cy="914400"/>
+          <a:off x="747713" y="2076004"/>
+          <a:ext cx="10696575" cy="914400"/>
         </p:xfrm>
         <a:graphic>
           <a:graphicData uri="http://schemas.openxmlformats.org/drawingml/2006/table">
             <a:tbl>
               <a:tblPr/>
               <a:tblGrid>
-                <a:gridCol w="3640455"/>
-                <a:gridCol w="3710464"/>
-                <a:gridCol w="3520440"/>
+                <a:gridCol w="3740468"/>
+                <a:gridCol w="3840480"/>
+                <a:gridCol w="3630454"/>
               </a:tblGrid>
               <a:tr h="0">
                 <a:tc>

</xml_diff>